<commit_message>
docs: enrich PowerPoint slides with much more material and technical information
</commit_message>
<xml_diff>
--- a/presentation_bmci_livekit.pptx
+++ b/presentation_bmci_livekit.pptx
@@ -3113,8 +3113,8 @@
         </p:nvSpPr>
         <p:spPr>
           <a:xfrm>
-            <a:off x="731520" y="457200"/>
-            <a:ext cx="10698480" cy="1097280"/>
+            <a:off x="731520" y="365760"/>
+            <a:ext cx="10698480" cy="1005840"/>
           </a:xfrm>
           <a:prstGeom prst="rect">
             <a:avLst/>
@@ -3149,8 +3149,8 @@
         </p:nvSpPr>
         <p:spPr>
           <a:xfrm>
-            <a:off x="731520" y="1371600"/>
-            <a:ext cx="10698480" cy="731520"/>
+            <a:off x="731520" y="1188720"/>
+            <a:ext cx="10698480" cy="640080"/>
           </a:xfrm>
           <a:prstGeom prst="rect">
             <a:avLst/>
@@ -3185,8 +3185,8 @@
         </p:nvSpPr>
         <p:spPr>
           <a:xfrm>
-            <a:off x="731520" y="2194560"/>
-            <a:ext cx="10698480" cy="4114800"/>
+            <a:off x="731520" y="1920240"/>
+            <a:ext cx="10698480" cy="4389120"/>
           </a:xfrm>
           <a:prstGeom prst="rect">
             <a:avLst/>
@@ -3201,9 +3201,9 @@
           <a:p>
             <a:pPr>
               <a:spcAft>
-                <a:spcPts val="1600"/>
+                <a:spcPts val="1200"/>
               </a:spcAft>
-              <a:defRPr sz="1800">
+              <a:defRPr sz="1700">
                 <a:solidFill>
                   <a:srgbClr val="E2E8F0"/>
                 </a:solidFill>
@@ -3211,15 +3211,15 @@
               </a:defRPr>
             </a:pPr>
             <a:r>
-              <a:t>•  Auteur : Stagiaire R&amp;D - BMCI</a:t>
+              <a:t>•  Contexte du Stage R&amp;D : Conception et évaluation d'agents conversationnels intelligents pour la formation interne des conseillers bancaires de la BMCI.</a:t>
             </a:r>
           </a:p>
           <a:p>
             <a:pPr>
               <a:spcAft>
-                <a:spcPts val="1600"/>
+                <a:spcPts val="1200"/>
               </a:spcAft>
-              <a:defRPr sz="1800">
+              <a:defRPr sz="1700">
                 <a:solidFill>
                   <a:srgbClr val="E2E8F0"/>
                 </a:solidFill>
@@ -3227,15 +3227,15 @@
               </a:defRPr>
             </a:pPr>
             <a:r>
-              <a:t>•  Objectif : Entraîner et évaluer des LLMs pour le rôle de client bancaire en colère.</a:t>
+              <a:t>•  Objectif Principal : Remplacer les simulations scriptées classiques par un agent IA doté d'une personnalité réactive, capable de simuler un client réaliste, impatient et mécontent.</a:t>
             </a:r>
           </a:p>
           <a:p>
             <a:pPr>
               <a:spcAft>
-                <a:spcPts val="1600"/>
+                <a:spcPts val="1200"/>
               </a:spcAft>
-              <a:defRPr sz="1800">
+              <a:defRPr sz="1700">
                 <a:solidFill>
                   <a:srgbClr val="E2E8F0"/>
                 </a:solidFill>
@@ -3243,7 +3243,7 @@
               </a:defRPr>
             </a:pPr>
             <a:r>
-              <a:t>•  Architecture : Modèles locaux fine-tunés, Interface Streamlit, LiveKit WebRTC.</a:t>
+              <a:t>•  Architecture Hybride : Combinaison de modèles de langage légers fine-tunés en local, d'un framework d'évaluation Streamlit et d'un agent vocal WebRTC en direct via LiveKit.</a:t>
             </a:r>
           </a:p>
         </p:txBody>
@@ -3282,8 +3282,8 @@
         </p:nvSpPr>
         <p:spPr>
           <a:xfrm>
-            <a:off x="731520" y="457200"/>
-            <a:ext cx="10698480" cy="1097280"/>
+            <a:off x="731520" y="365760"/>
+            <a:ext cx="10698480" cy="1005840"/>
           </a:xfrm>
           <a:prstGeom prst="rect">
             <a:avLst/>
@@ -3318,8 +3318,8 @@
         </p:nvSpPr>
         <p:spPr>
           <a:xfrm>
-            <a:off x="731520" y="1371600"/>
-            <a:ext cx="10698480" cy="731520"/>
+            <a:off x="731520" y="1188720"/>
+            <a:ext cx="10698480" cy="640080"/>
           </a:xfrm>
           <a:prstGeom prst="rect">
             <a:avLst/>
@@ -3354,8 +3354,8 @@
         </p:nvSpPr>
         <p:spPr>
           <a:xfrm>
-            <a:off x="731520" y="2194560"/>
-            <a:ext cx="10698480" cy="4114800"/>
+            <a:off x="731520" y="1920240"/>
+            <a:ext cx="10698480" cy="4389120"/>
           </a:xfrm>
           <a:prstGeom prst="rect">
             <a:avLst/>
@@ -3370,9 +3370,9 @@
           <a:p>
             <a:pPr>
               <a:spcAft>
-                <a:spcPts val="1600"/>
+                <a:spcPts val="1200"/>
               </a:spcAft>
-              <a:defRPr sz="1800">
+              <a:defRPr sz="1700">
                 <a:solidFill>
                   <a:srgbClr val="E2E8F0"/>
                 </a:solidFill>
@@ -3380,15 +3380,15 @@
               </a:defRPr>
             </a:pPr>
             <a:r>
-              <a:t>•  Dataset de fine-tuning : Enrichir avec plus d'exemples de sécurité et de résistance aux pièges du conseiller.</a:t>
+              <a:t>•  Enrichissement du Dataset de Fine-Tuning : Ajouter des exemples pour apprendre au modèle à résister aux pièges du conseiller, refuser de divulguer des données sensibles, et respecter le contexte.</a:t>
             </a:r>
           </a:p>
           <a:p>
             <a:pPr>
               <a:spcAft>
-                <a:spcPts val="1600"/>
+                <a:spcPts val="1200"/>
               </a:spcAft>
-              <a:defRPr sz="1800">
+              <a:defRPr sz="1700">
                 <a:solidFill>
                   <a:srgbClr val="E2E8F0"/>
                 </a:solidFill>
@@ -3396,15 +3396,15 @@
               </a:defRPr>
             </a:pPr>
             <a:r>
-              <a:t>•  Checkpoints Kaggle : Automatiser la reprise et stabiliser l'export des poids fins.</a:t>
+              <a:t>•  Stabilisation des checkpints : Automatiser la reprise et sécuriser l'exportation des poids LoRA fins vers Hugging Face.</a:t>
             </a:r>
           </a:p>
           <a:p>
             <a:pPr>
               <a:spcAft>
-                <a:spcPts val="1600"/>
+                <a:spcPts val="1200"/>
               </a:spcAft>
-              <a:defRPr sz="1800">
+              <a:defRPr sz="1700">
                 <a:solidFill>
                   <a:srgbClr val="E2E8F0"/>
                 </a:solidFill>
@@ -3412,7 +3412,7 @@
               </a:defRPr>
             </a:pPr>
             <a:r>
-              <a:t>•  Speech-to-Speech : Évaluer la viabilité financière de l'hébergement cloud GPU pour Moshi.</a:t>
+              <a:t>•  Speech-to-Speech (S2S) : Évaluer la viabilité financière de l'hébergement cloud GPU pour Moshi ou tester l'intégration d'OpenAI Realtime API / Gemini Live API.</a:t>
             </a:r>
           </a:p>
         </p:txBody>
@@ -3451,8 +3451,8 @@
         </p:nvSpPr>
         <p:spPr>
           <a:xfrm>
-            <a:off x="731520" y="457200"/>
-            <a:ext cx="10698480" cy="1097280"/>
+            <a:off x="731520" y="365760"/>
+            <a:ext cx="10698480" cy="1005840"/>
           </a:xfrm>
           <a:prstGeom prst="rect">
             <a:avLst/>
@@ -3487,8 +3487,8 @@
         </p:nvSpPr>
         <p:spPr>
           <a:xfrm>
-            <a:off x="731520" y="1371600"/>
-            <a:ext cx="10698480" cy="731520"/>
+            <a:off x="731520" y="1188720"/>
+            <a:ext cx="10698480" cy="640080"/>
           </a:xfrm>
           <a:prstGeom prst="rect">
             <a:avLst/>
@@ -3523,8 +3523,8 @@
         </p:nvSpPr>
         <p:spPr>
           <a:xfrm>
-            <a:off x="731520" y="2194560"/>
-            <a:ext cx="10698480" cy="4114800"/>
+            <a:off x="731520" y="1920240"/>
+            <a:ext cx="10698480" cy="4389120"/>
           </a:xfrm>
           <a:prstGeom prst="rect">
             <a:avLst/>
@@ -3539,9 +3539,9 @@
           <a:p>
             <a:pPr>
               <a:spcAft>
-                <a:spcPts val="1600"/>
+                <a:spcPts val="1200"/>
               </a:spcAft>
-              <a:defRPr sz="1800">
+              <a:defRPr sz="1700">
                 <a:solidFill>
                   <a:srgbClr val="E2E8F0"/>
                 </a:solidFill>
@@ -3549,15 +3549,15 @@
               </a:defRPr>
             </a:pPr>
             <a:r>
-              <a:t>•  Scénario : Retrait urgent de 100 000 dirhams pour l'achat d'une maison (limite journalière de 50 000 DH).</a:t>
+              <a:t>•  Le Scénario Métier : Retrait urgent de 100 000 DH pour finaliser l'achat d'une maison aujourd'hui avant midi. Le vendeur menace de vendre à un autre acheteur si les fonds ne sont pas remis.</a:t>
             </a:r>
           </a:p>
           <a:p>
             <a:pPr>
               <a:spcAft>
-                <a:spcPts val="1600"/>
+                <a:spcPts val="1200"/>
               </a:spcAft>
-              <a:defRPr sz="1800">
+              <a:defRPr sz="1700">
                 <a:solidFill>
                   <a:srgbClr val="E2E8F0"/>
                 </a:solidFill>
@@ -3565,15 +3565,15 @@
               </a:defRPr>
             </a:pPr>
             <a:r>
-              <a:t>•  Expressivité : Voix exprimant la colère et l'impatience (Mistral Voxtral 'Marie angry').</a:t>
+              <a:t>•  Le Conflit Réglementaire : La politique de sécurité BMCI limite les retraits immédiats en espèces à 50 000 DH par jour sans préavis. Le conseiller doit calmer le client et négocier une alternative.</a:t>
             </a:r>
           </a:p>
           <a:p>
             <a:pPr>
               <a:spcAft>
-                <a:spcPts val="1600"/>
+                <a:spcPts val="1200"/>
               </a:spcAft>
-              <a:defRPr sz="1800">
+              <a:defRPr sz="1700">
                 <a:solidFill>
                   <a:srgbClr val="E2E8F0"/>
                 </a:solidFill>
@@ -3581,7 +3581,55 @@
               </a:defRPr>
             </a:pPr>
             <a:r>
-              <a:t>•  Barge-in : Interruption instantanée de l'agent dès que l'utilisateur prend la parole.</a:t>
+              <a:t>•  Exigences Techniques Clés :</a:t>
+            </a:r>
+          </a:p>
+          <a:p>
+            <a:pPr lvl="1">
+              <a:spcAft>
+                <a:spcPts val="800"/>
+              </a:spcAft>
+              <a:defRPr sz="1600">
+                <a:solidFill>
+                  <a:srgbClr val="E2E8F0"/>
+                </a:solidFill>
+                <a:latin typeface="Arial"/>
+              </a:defRPr>
+            </a:pPr>
+            <a:r>
+              <a:t>  - Intonation Émotionnelle : La voix de l'IA doit exprimer une colère et une impatience audibles.</a:t>
+            </a:r>
+          </a:p>
+          <a:p>
+            <a:pPr lvl="1">
+              <a:spcAft>
+                <a:spcPts val="800"/>
+              </a:spcAft>
+              <a:defRPr sz="1600">
+                <a:solidFill>
+                  <a:srgbClr val="E2E8F0"/>
+                </a:solidFill>
+                <a:latin typeface="Arial"/>
+              </a:defRPr>
+            </a:pPr>
+            <a:r>
+              <a:t>  - Barge-in (Interruption) : L'agent doit s'arrêter de parler dès que l'apprenant prend la parole.</a:t>
+            </a:r>
+          </a:p>
+          <a:p>
+            <a:pPr lvl="1">
+              <a:spcAft>
+                <a:spcPts val="800"/>
+              </a:spcAft>
+              <a:defRPr sz="1600">
+                <a:solidFill>
+                  <a:srgbClr val="E2E8F0"/>
+                </a:solidFill>
+                <a:latin typeface="Arial"/>
+              </a:defRPr>
+            </a:pPr>
+            <a:r>
+              <a:t>  - Latence de Conversation : Le temps de réponse doit être inférieur à 1,5s pour rester naturel.</a:t>
             </a:r>
           </a:p>
         </p:txBody>
@@ -3620,8 +3668,8 @@
         </p:nvSpPr>
         <p:spPr>
           <a:xfrm>
-            <a:off x="731520" y="457200"/>
-            <a:ext cx="10698480" cy="1097280"/>
+            <a:off x="731520" y="365760"/>
+            <a:ext cx="10698480" cy="1005840"/>
           </a:xfrm>
           <a:prstGeom prst="rect">
             <a:avLst/>
@@ -3656,8 +3704,8 @@
         </p:nvSpPr>
         <p:spPr>
           <a:xfrm>
-            <a:off x="731520" y="1371600"/>
-            <a:ext cx="10698480" cy="731520"/>
+            <a:off x="731520" y="1188720"/>
+            <a:ext cx="10698480" cy="640080"/>
           </a:xfrm>
           <a:prstGeom prst="rect">
             <a:avLst/>
@@ -3679,7 +3727,7 @@
               </a:defRPr>
             </a:pPr>
             <a:r>
-              <a:t>Adapter les LLMs au Métier Bancaire</a:t>
+              <a:t>Adapter les LLMs au Métier Bancaire et au Jeu de Rôle</a:t>
             </a:r>
           </a:p>
         </p:txBody>
@@ -3692,8 +3740,8 @@
         </p:nvSpPr>
         <p:spPr>
           <a:xfrm>
-            <a:off x="731520" y="2194560"/>
-            <a:ext cx="10698480" cy="4114800"/>
+            <a:off x="731520" y="1920240"/>
+            <a:ext cx="10698480" cy="4389120"/>
           </a:xfrm>
           <a:prstGeom prst="rect">
             <a:avLst/>
@@ -3708,9 +3756,9 @@
           <a:p>
             <a:pPr>
               <a:spcAft>
-                <a:spcPts val="1600"/>
+                <a:spcPts val="1200"/>
               </a:spcAft>
-              <a:defRPr sz="1800">
+              <a:defRPr sz="1700">
                 <a:solidFill>
                   <a:srgbClr val="E2E8F0"/>
                 </a:solidFill>
@@ -3718,15 +3766,15 @@
               </a:defRPr>
             </a:pPr>
             <a:r>
-              <a:t>•  Création d'un Dataset Fictif BMCI : Échanges de négociation sur 9 cas (carte bloquée, crédit, frais...).</a:t>
+              <a:t>•  Constitution du Dataset BMCI : Création d'un ensemble de données en français simulant des conversations client-conseiller sur 9 thématiques (carte bloquée, crédit, frais bancaires, chèque, plafond...).</a:t>
             </a:r>
           </a:p>
           <a:p>
             <a:pPr>
               <a:spcAft>
-                <a:spcPts val="1600"/>
+                <a:spcPts val="1200"/>
               </a:spcAft>
-              <a:defRPr sz="1800">
+              <a:defRPr sz="1700">
                 <a:solidFill>
                   <a:srgbClr val="E2E8F0"/>
                 </a:solidFill>
@@ -3734,15 +3782,15 @@
               </a:defRPr>
             </a:pPr>
             <a:r>
-              <a:t>•  Fine-Tuning LoRA (Low-Rank Adaptation) : Entraînements sur Qwen, SmolLM2, TinyLlama, BloomZ et CroissantLLM.</a:t>
+              <a:t>•  Fine-Tuning LoRA (Low-Rank Adaptation) : Entraînement sur architectures légères (Qwen, SmolLM2, TinyLlama, BloomZ, CroissantLLM) pour permettre l'exécution sur des PC d'agences sans ressources GPU.</a:t>
             </a:r>
           </a:p>
           <a:p>
             <a:pPr>
               <a:spcAft>
-                <a:spcPts val="1600"/>
+                <a:spcPts val="1200"/>
               </a:spcAft>
-              <a:defRPr sz="1800">
+              <a:defRPr sz="1700">
                 <a:solidFill>
                   <a:srgbClr val="E2E8F0"/>
                 </a:solidFill>
@@ -3750,7 +3798,7 @@
               </a:defRPr>
             </a:pPr>
             <a:r>
-              <a:t>•  Modèle local le plus exploitable : Qwen2.5-0.5B-BMCI-Client-Finetune-1.</a:t>
+              <a:t>•  Résultat Principal : Le modèle 'Qwen2.5-0.5B-BMCI-Client-Finetune-1' est retenu comme le plus exploitable en local, offrant une bonne réactivité et un respect satisfaisant de la langue française.</a:t>
             </a:r>
           </a:p>
         </p:txBody>
@@ -3789,8 +3837,8 @@
         </p:nvSpPr>
         <p:spPr>
           <a:xfrm>
-            <a:off x="731520" y="457200"/>
-            <a:ext cx="10698480" cy="1097280"/>
+            <a:off x="731520" y="365760"/>
+            <a:ext cx="10698480" cy="1005840"/>
           </a:xfrm>
           <a:prstGeom prst="rect">
             <a:avLst/>
@@ -3825,8 +3873,8 @@
         </p:nvSpPr>
         <p:spPr>
           <a:xfrm>
-            <a:off x="731520" y="1371600"/>
-            <a:ext cx="10698480" cy="731520"/>
+            <a:off x="731520" y="1188720"/>
+            <a:ext cx="10698480" cy="640080"/>
           </a:xfrm>
           <a:prstGeom prst="rect">
             <a:avLst/>
@@ -3861,8 +3909,8 @@
         </p:nvSpPr>
         <p:spPr>
           <a:xfrm>
-            <a:off x="731520" y="2194560"/>
-            <a:ext cx="10698480" cy="4114800"/>
+            <a:off x="731520" y="1920240"/>
+            <a:ext cx="10698480" cy="4389120"/>
           </a:xfrm>
           <a:prstGeom prst="rect">
             <a:avLst/>
@@ -3877,9 +3925,9 @@
           <a:p>
             <a:pPr>
               <a:spcAft>
-                <a:spcPts val="1600"/>
+                <a:spcPts val="1200"/>
               </a:spcAft>
-              <a:defRPr sz="1800">
+              <a:defRPr sz="1700">
                 <a:solidFill>
                   <a:srgbClr val="E2E8F0"/>
                 </a:solidFill>
@@ -3887,15 +3935,15 @@
               </a:defRPr>
             </a:pPr>
             <a:r>
-              <a:t>•  Respect du rôle client : Tendance naturelle du LLM à conseiller -&gt; Prompts stricts, few-shot et filtres post-génération.</a:t>
+              <a:t>•  Respect du Rôle (Sortie de Rôle) : Les modèles instruct ont tendance à conseiller l'utilisateur au lieu de jouer le client mécontent. Résolu par des prompts système stricts et des filtres post-génération.</a:t>
             </a:r>
           </a:p>
           <a:p>
             <a:pPr>
               <a:spcAft>
-                <a:spcPts val="1600"/>
+                <a:spcPts val="1200"/>
               </a:spcAft>
-              <a:defRPr sz="1800">
+              <a:defRPr sz="1700">
                 <a:solidFill>
                   <a:srgbClr val="E2E8F0"/>
                 </a:solidFill>
@@ -3903,15 +3951,15 @@
               </a:defRPr>
             </a:pPr>
             <a:r>
-              <a:t>•  Dérives de contexte : Perte du sujet de départ -&gt; Nécessité de recentrer le modèle par plus d'exemples de dialogue.</a:t>
+              <a:t>•  Dérives Contextuelles : Le modèle fine-tuné dérive parfois du scénario d'origine (ex: parler de crédit au milieu d'un cas de carte bloquée). Nécessite un enrichissement du dataset avec des cas de recentrage.</a:t>
             </a:r>
           </a:p>
           <a:p>
             <a:pPr>
               <a:spcAft>
-                <a:spcPts val="1600"/>
+                <a:spcPts val="1200"/>
               </a:spcAft>
-              <a:defRPr sz="1800">
+              <a:defRPr sz="1700">
                 <a:solidFill>
                   <a:srgbClr val="E2E8F0"/>
                 </a:solidFill>
@@ -3919,15 +3967,15 @@
               </a:defRPr>
             </a:pPr>
             <a:r>
-              <a:t>•  Absence de GPU local : Entraînement sur CPU impossible -&gt; Déportation vers Kaggle/Colab et blocage local de Mistral 7B.</a:t>
+              <a:t>•  Absence de GPU NVIDIA Local : GPU Intel Windows incompatible CUDA. Obligation de basculer l'entraînement LoRA sur Kaggle/Colab et de bloquer localement Mistral 7B pour éviter les crashs de RAM.</a:t>
             </a:r>
           </a:p>
           <a:p>
             <a:pPr>
               <a:spcAft>
-                <a:spcPts val="1600"/>
+                <a:spcPts val="1200"/>
               </a:spcAft>
-              <a:defRPr sz="1800">
+              <a:defRPr sz="1700">
                 <a:solidFill>
                   <a:srgbClr val="E2E8F0"/>
                 </a:solidFill>
@@ -3935,7 +3983,7 @@
               </a:defRPr>
             </a:pPr>
             <a:r>
-              <a:t>•  Checkpoints et Dépendances : Crashs de disques Colab et conflits de packages -&gt; Scripts de sauvegarde automatique vers Drive.</a:t>
+              <a:t>•  Checkpoints et Dépendances : Déconnexions fréquentes sur Colab/Kaggle perdant les checkpoints. Implémentation d'une sauvegarde automatique vers Google Drive et résolution des conflits packages peft/transformers.</a:t>
             </a:r>
           </a:p>
         </p:txBody>
@@ -3974,8 +4022,8 @@
         </p:nvSpPr>
         <p:spPr>
           <a:xfrm>
-            <a:off x="731520" y="457200"/>
-            <a:ext cx="10698480" cy="1097280"/>
+            <a:off x="731520" y="365760"/>
+            <a:ext cx="10698480" cy="1005840"/>
           </a:xfrm>
           <a:prstGeom prst="rect">
             <a:avLst/>
@@ -4010,8 +4058,8 @@
         </p:nvSpPr>
         <p:spPr>
           <a:xfrm>
-            <a:off x="731520" y="1371600"/>
-            <a:ext cx="10698480" cy="731520"/>
+            <a:off x="731520" y="1188720"/>
+            <a:ext cx="10698480" cy="640080"/>
           </a:xfrm>
           <a:prstGeom prst="rect">
             <a:avLst/>
@@ -4046,8 +4094,8 @@
         </p:nvSpPr>
         <p:spPr>
           <a:xfrm>
-            <a:off x="731520" y="2194560"/>
-            <a:ext cx="10698480" cy="4114800"/>
+            <a:off x="731520" y="1920240"/>
+            <a:ext cx="10698480" cy="4389120"/>
           </a:xfrm>
           <a:prstGeom prst="rect">
             <a:avLst/>
@@ -4062,9 +4110,9 @@
           <a:p>
             <a:pPr>
               <a:spcAft>
-                <a:spcPts val="1600"/>
+                <a:spcPts val="1200"/>
               </a:spcAft>
-              <a:defRPr sz="1800">
+              <a:defRPr sz="1700">
                 <a:solidFill>
                   <a:srgbClr val="E2E8F0"/>
                 </a:solidFill>
@@ -4072,15 +4120,15 @@
               </a:defRPr>
             </a:pPr>
             <a:r>
-              <a:t>•  Application Streamlit : Interface de chat client BMCI, onglet évaluation et garde-fous de rôle.</a:t>
+              <a:t>•  Interface Streamlit Adaptée : Ajout d'un onglet de Chat Client BMCI, d'un onglet d'Évaluation automatique, et d'un système de blocage des réponses hors-rôle.</a:t>
             </a:r>
           </a:p>
           <a:p>
             <a:pPr>
               <a:spcAft>
-                <a:spcPts val="1600"/>
+                <a:spcPts val="1200"/>
               </a:spcAft>
-              <a:defRPr sz="1800">
+              <a:defRPr sz="1700">
                 <a:solidFill>
                   <a:srgbClr val="E2E8F0"/>
                 </a:solidFill>
@@ -4088,15 +4136,15 @@
               </a:defRPr>
             </a:pPr>
             <a:r>
-              <a:t>•  Framework d'Évaluation : Scénarios multi-modèles (Promptfoo) + Red-Teaming (attaques vocales).</a:t>
-            </a:r>
-          </a:p>
-          <a:p>
-            <a:pPr>
+              <a:t>•  Framework d'Évaluation Automatique :</a:t>
+            </a:r>
+          </a:p>
+          <a:p>
+            <a:pPr lvl="1">
               <a:spcAft>
-                <a:spcPts val="1600"/>
+                <a:spcPts val="800"/>
               </a:spcAft>
-              <a:defRPr sz="1800">
+              <a:defRPr sz="1600">
                 <a:solidFill>
                   <a:srgbClr val="E2E8F0"/>
                 </a:solidFill>
@@ -4104,7 +4152,39 @@
               </a:defRPr>
             </a:pPr>
             <a:r>
-              <a:t>•  Scoring G-Eval &amp; RAGAS : Mesure du respect du rôle, pertinence, sécurité, et claims non supportés.</a:t>
+              <a:t>  - Scénarios Multi-Modèles (approche Promptfoo) : Comparaison des réponses face à des cas de Red-Teaming.</a:t>
+            </a:r>
+          </a:p>
+          <a:p>
+            <a:pPr lvl="1">
+              <a:spcAft>
+                <a:spcPts val="800"/>
+              </a:spcAft>
+              <a:defRPr sz="1600">
+                <a:solidFill>
+                  <a:srgbClr val="E2E8F0"/>
+                </a:solidFill>
+                <a:latin typeface="Arial"/>
+              </a:defRPr>
+            </a:pPr>
+            <a:r>
+              <a:t>  - Scoring G-Eval / DeepEval (LLM-as-a-judge) : Évaluation par des LLMs supérieurs des critères de rôle, pertinence, et concision.</a:t>
+            </a:r>
+          </a:p>
+          <a:p>
+            <a:pPr lvl="1">
+              <a:spcAft>
+                <a:spcPts val="800"/>
+              </a:spcAft>
+              <a:defRPr sz="1600">
+                <a:solidFill>
+                  <a:srgbClr val="E2E8F0"/>
+                </a:solidFill>
+                <a:latin typeface="Arial"/>
+              </a:defRPr>
+            </a:pPr>
+            <a:r>
+              <a:t>  - Fidélité (proxy RAGAS) : Mesure de la cohérence logique et détection d'hallucinations.</a:t>
             </a:r>
           </a:p>
         </p:txBody>
@@ -4143,8 +4223,8 @@
         </p:nvSpPr>
         <p:spPr>
           <a:xfrm>
-            <a:off x="731520" y="457200"/>
-            <a:ext cx="10698480" cy="1097280"/>
+            <a:off x="731520" y="365760"/>
+            <a:ext cx="10698480" cy="1005840"/>
           </a:xfrm>
           <a:prstGeom prst="rect">
             <a:avLst/>
@@ -4166,7 +4246,7 @@
               </a:defRPr>
             </a:pPr>
             <a:r>
-              <a:t>Phase 2 : Benchmark STT (Écoute)</a:t>
+              <a:t>Phase 2 : Benchmark STT (Reconnaissance Vocale)</a:t>
             </a:r>
           </a:p>
         </p:txBody>
@@ -4179,8 +4259,8 @@
         </p:nvSpPr>
         <p:spPr>
           <a:xfrm>
-            <a:off x="731520" y="1371600"/>
-            <a:ext cx="10698480" cy="731520"/>
+            <a:off x="731520" y="1188720"/>
+            <a:ext cx="10698480" cy="640080"/>
           </a:xfrm>
           <a:prstGeom prst="rect">
             <a:avLst/>
@@ -4215,8 +4295,8 @@
         </p:nvSpPr>
         <p:spPr>
           <a:xfrm>
-            <a:off x="731520" y="2194560"/>
-            <a:ext cx="10698480" cy="4114800"/>
+            <a:off x="731520" y="1920240"/>
+            <a:ext cx="10698480" cy="4389120"/>
           </a:xfrm>
           <a:prstGeom prst="rect">
             <a:avLst/>
@@ -4231,9 +4311,25 @@
           <a:p>
             <a:pPr>
               <a:spcAft>
-                <a:spcPts val="1600"/>
+                <a:spcPts val="1200"/>
               </a:spcAft>
-              <a:defRPr sz="1800">
+              <a:defRPr sz="1700">
+                <a:solidFill>
+                  <a:srgbClr val="FFFFFF"/>
+                </a:solidFill>
+                <a:latin typeface="Arial"/>
+              </a:defRPr>
+            </a:pPr>
+            <a:r>
+              <a:t>•  🟢 Réussite - Cohere Transcribe v2 (Cloud) : Taux d'erreur de mots (WER) de 5.82%. Très précis, ultra-rapide en streaming, et extrêmement robuste aux bruits de fond d'agence et aux accents.</a:t>
+            </a:r>
+          </a:p>
+          <a:p>
+            <a:pPr>
+              <a:spcAft>
+                <a:spcPts val="1200"/>
+              </a:spcAft>
+              <a:defRPr sz="1700">
                 <a:solidFill>
                   <a:srgbClr val="E2E8F0"/>
                 </a:solidFill>
@@ -4241,15 +4337,15 @@
               </a:defRPr>
             </a:pPr>
             <a:r>
-              <a:t>•  🟢 Réussite - Cohere Transcribe v2 (Cloud) : Taux d'erreur de mots (WER) très bas (5.82%), ultra-rapide et robuste.</a:t>
+              <a:t>•  🔴 Non Concluant - ElevenLabs Scribe v2 (Cloud) : Précision exceptionnelle (WER 3.12%), mais sa latence de 21 secondes le rend totalement inutilisable pour une conversation vocale en direct.</a:t>
             </a:r>
           </a:p>
           <a:p>
             <a:pPr>
               <a:spcAft>
-                <a:spcPts val="1600"/>
+                <a:spcPts val="1200"/>
               </a:spcAft>
-              <a:defRPr sz="1800">
+              <a:defRPr sz="1700">
                 <a:solidFill>
                   <a:srgbClr val="E2E8F0"/>
                 </a:solidFill>
@@ -4257,23 +4353,7 @@
               </a:defRPr>
             </a:pPr>
             <a:r>
-              <a:t>•  🔴 Non Concluant - ElevenLabs Scribe v2 (Cloud) : Excellente transcription mais latence de 21s (inutilisable en direct).</a:t>
-            </a:r>
-          </a:p>
-          <a:p>
-            <a:pPr>
-              <a:spcAft>
-                <a:spcPts val="1600"/>
-              </a:spcAft>
-              <a:defRPr sz="1800">
-                <a:solidFill>
-                  <a:srgbClr val="E2E8F0"/>
-                </a:solidFill>
-                <a:latin typeface="Arial"/>
-              </a:defRPr>
-            </a:pPr>
-            <a:r>
-              <a:t>•  🔴 Non Concluant - Whisper Large-Turbo (Local) : Trop lourd en calcul sur le CPU local (132s pour 3 min de voix).</a:t>
+              <a:t>•  🔴 Non Concluant - Whisper Large-Turbo (Local) : Taux d'erreur correct (6.03%), mais demande 132s de traitement CPU pour 3 min de voix. Impossible à utiliser sans carte graphique NVIDIA locale.</a:t>
             </a:r>
           </a:p>
         </p:txBody>
@@ -4312,8 +4392,8 @@
         </p:nvSpPr>
         <p:spPr>
           <a:xfrm>
-            <a:off x="731520" y="457200"/>
-            <a:ext cx="10698480" cy="1097280"/>
+            <a:off x="731520" y="365760"/>
+            <a:ext cx="10698480" cy="1005840"/>
           </a:xfrm>
           <a:prstGeom prst="rect">
             <a:avLst/>
@@ -4335,7 +4415,7 @@
               </a:defRPr>
             </a:pPr>
             <a:r>
-              <a:t>Phase 2 : Benchmark TTS (Voix)</a:t>
+              <a:t>Phase 2 : Benchmark TTS (Synthèse Vocale)</a:t>
             </a:r>
           </a:p>
         </p:txBody>
@@ -4348,8 +4428,8 @@
         </p:nvSpPr>
         <p:spPr>
           <a:xfrm>
-            <a:off x="731520" y="1371600"/>
-            <a:ext cx="10698480" cy="731520"/>
+            <a:off x="731520" y="1188720"/>
+            <a:ext cx="10698480" cy="640080"/>
           </a:xfrm>
           <a:prstGeom prst="rect">
             <a:avLst/>
@@ -4384,8 +4464,8 @@
         </p:nvSpPr>
         <p:spPr>
           <a:xfrm>
-            <a:off x="731520" y="2194560"/>
-            <a:ext cx="10698480" cy="4114800"/>
+            <a:off x="731520" y="1920240"/>
+            <a:ext cx="10698480" cy="4389120"/>
           </a:xfrm>
           <a:prstGeom prst="rect">
             <a:avLst/>
@@ -4400,9 +4480,25 @@
           <a:p>
             <a:pPr>
               <a:spcAft>
-                <a:spcPts val="1600"/>
+                <a:spcPts val="1200"/>
               </a:spcAft>
-              <a:defRPr sz="1800">
+              <a:defRPr sz="1700">
+                <a:solidFill>
+                  <a:srgbClr val="FFFFFF"/>
+                </a:solidFill>
+                <a:latin typeface="Arial"/>
+              </a:defRPr>
+            </a:pPr>
+            <a:r>
+              <a:t>•  🟢 Réussite - Mistral Voxtral (Marie angry) : Voix nativement en colère extrêmement réaliste. Latence réseau faible (1.57s) et quotas d'API très fiables pour les phases de test.</a:t>
+            </a:r>
+          </a:p>
+          <a:p>
+            <a:pPr>
+              <a:spcAft>
+                <a:spcPts val="1200"/>
+              </a:spcAft>
+              <a:defRPr sz="1700">
                 <a:solidFill>
                   <a:srgbClr val="E2E8F0"/>
                 </a:solidFill>
@@ -4410,15 +4506,15 @@
               </a:defRPr>
             </a:pPr>
             <a:r>
-              <a:t>•  🟢 Réussite - Mistral Voxtral (Marie angry) : Colère native très réaliste, latence faible (1.57s) et quotas d'API fiables.</a:t>
+              <a:t>•  🔴 Non Concluant - Hume AI (Cloud) : Qualité vocale et naturelle inégalées (MOS 4.03), mais l'API d'essai gratuite s'est bloquée sous l'effet d'erreurs HTTP 429 (Too Many Requests) lors d'échanges rapides.</a:t>
             </a:r>
           </a:p>
           <a:p>
             <a:pPr>
               <a:spcAft>
-                <a:spcPts val="1600"/>
+                <a:spcPts val="1200"/>
               </a:spcAft>
-              <a:defRPr sz="1800">
+              <a:defRPr sz="1700">
                 <a:solidFill>
                   <a:srgbClr val="E2E8F0"/>
                 </a:solidFill>
@@ -4426,15 +4522,15 @@
               </a:defRPr>
             </a:pPr>
             <a:r>
-              <a:t>•  🔴 Non Concluant - Hume AI (Cloud) : Voix ultra-naturelle (MOS 4.03) mais bloquée par des quotas d'essai trop stricts (429).</a:t>
+              <a:t>•  🔴 Non Concluant - F5-TTS (Local) : Qualité de clonage excellente (MOS 3.79), mais demande 128s de calcul sur CPU local pour 3s de voix. Inexploitable en direct.</a:t>
             </a:r>
           </a:p>
           <a:p>
             <a:pPr>
               <a:spcAft>
-                <a:spcPts val="1600"/>
+                <a:spcPts val="1200"/>
               </a:spcAft>
-              <a:defRPr sz="1800">
+              <a:defRPr sz="1700">
                 <a:solidFill>
                   <a:srgbClr val="E2E8F0"/>
                 </a:solidFill>
@@ -4442,23 +4538,7 @@
               </a:defRPr>
             </a:pPr>
             <a:r>
-              <a:t>•  🔴 Non Concluant - F5-TTS (Local) : Inférence impossible en direct sur CPU (128s de calcul pour 3s de voix).</a:t>
-            </a:r>
-          </a:p>
-          <a:p>
-            <a:pPr>
-              <a:spcAft>
-                <a:spcPts val="1600"/>
-              </a:spcAft>
-              <a:defRPr sz="1800">
-                <a:solidFill>
-                  <a:srgbClr val="E2E8F0"/>
-                </a:solidFill>
-                <a:latin typeface="Arial"/>
-              </a:defRPr>
-            </a:pPr>
-            <a:r>
-              <a:t>•  🔴 Non Concluant - Kokoro &amp; MeloTTS (Locaux) : Voix françaises trop neutres, robotiques et manquant d'intonation émotionnelle.</a:t>
+              <a:t>•  🔴 Non Concluant - Kokoro &amp; MeloTTS (Locaux) : Inférence plus rapide, mais voix françaises trop robotiques, plates, et incapables de restituer l'intonation fâchée ou agressive.</a:t>
             </a:r>
           </a:p>
         </p:txBody>
@@ -4497,8 +4577,8 @@
         </p:nvSpPr>
         <p:spPr>
           <a:xfrm>
-            <a:off x="731520" y="457200"/>
-            <a:ext cx="10698480" cy="1097280"/>
+            <a:off x="731520" y="365760"/>
+            <a:ext cx="10698480" cy="1005840"/>
           </a:xfrm>
           <a:prstGeom prst="rect">
             <a:avLst/>
@@ -4533,8 +4613,8 @@
         </p:nvSpPr>
         <p:spPr>
           <a:xfrm>
-            <a:off x="731520" y="1371600"/>
-            <a:ext cx="10698480" cy="731520"/>
+            <a:off x="731520" y="1188720"/>
+            <a:ext cx="10698480" cy="640080"/>
           </a:xfrm>
           <a:prstGeom prst="rect">
             <a:avLst/>
@@ -4569,8 +4649,8 @@
         </p:nvSpPr>
         <p:spPr>
           <a:xfrm>
-            <a:off x="731520" y="2194560"/>
-            <a:ext cx="10698480" cy="4114800"/>
+            <a:off x="731520" y="1920240"/>
+            <a:ext cx="10698480" cy="4389120"/>
           </a:xfrm>
           <a:prstGeom prst="rect">
             <a:avLst/>
@@ -4585,9 +4665,25 @@
           <a:p>
             <a:pPr>
               <a:spcAft>
-                <a:spcPts val="1600"/>
+                <a:spcPts val="1200"/>
               </a:spcAft>
-              <a:defRPr sz="1800">
+              <a:defRPr sz="1700">
+                <a:solidFill>
+                  <a:srgbClr val="FFFFFF"/>
+                </a:solidFill>
+                <a:latin typeface="Arial"/>
+              </a:defRPr>
+            </a:pPr>
+            <a:r>
+              <a:t>•  Avantages LiveKit WebRTC : Gestion native du Full-Duplex (parole simultanée) et du Barge-in (l'IA se tait instantanément dès que l'utilisateur l'interrompt).</a:t>
+            </a:r>
+          </a:p>
+          <a:p>
+            <a:pPr>
+              <a:spcAft>
+                <a:spcPts val="1200"/>
+              </a:spcAft>
+              <a:defRPr sz="1700">
                 <a:solidFill>
                   <a:srgbClr val="E2E8F0"/>
                 </a:solidFill>
@@ -4595,15 +4691,15 @@
               </a:defRPr>
             </a:pPr>
             <a:r>
-              <a:t>•  Avantages LiveKit : Full-Duplex (parole simultanée) et Barge-in (interruption millisecondée de l'IA).</a:t>
+              <a:t>•  Gestion fine de la détection de silence : Configuration de l'option de VAD (Voice Activity Detection) avec un min_delay fixe de 0.8s pour donner le temps au STT de finaliser sa transcription.</a:t>
             </a:r>
           </a:p>
           <a:p>
             <a:pPr>
               <a:spcAft>
-                <a:spcPts val="1600"/>
+                <a:spcPts val="1200"/>
               </a:spcAft>
-              <a:defRPr sz="1800">
+              <a:defRPr sz="1700">
                 <a:solidFill>
                   <a:srgbClr val="E2E8F0"/>
                 </a:solidFill>
@@ -4611,15 +4707,15 @@
               </a:defRPr>
             </a:pPr>
             <a:r>
-              <a:t>•  Ajustements de fluidité : Temps de pause minimal (0.8s) pour laisser le temps au STT de finaliser.</a:t>
+              <a:t>•  Filtre de formatage et d'anti-épellation : Nettoyage automatique par expressions régulières (Regex) des crochets d'émotions [gasp] et conversion des mots en majuscules (ex: MON -&gt; mon) pour éviter que la voix ne les épelle.</a:t>
             </a:r>
           </a:p>
           <a:p>
             <a:pPr>
               <a:spcAft>
-                <a:spcPts val="1600"/>
+                <a:spcPts val="1200"/>
               </a:spcAft>
-              <a:defRPr sz="1800">
+              <a:defRPr sz="1700">
                 <a:solidFill>
                   <a:srgbClr val="E2E8F0"/>
                 </a:solidFill>
@@ -4627,23 +4723,7 @@
               </a:defRPr>
             </a:pPr>
             <a:r>
-              <a:t>•  Filtre anti-didacalies : Retrait automatique des crochets et majuscules pour éviter que la voix ne les épelle.</a:t>
-            </a:r>
-          </a:p>
-          <a:p>
-            <a:pPr>
-              <a:spcAft>
-                <a:spcPts val="1600"/>
-              </a:spcAft>
-              <a:defRPr sz="1800">
-                <a:solidFill>
-                  <a:srgbClr val="E2E8F0"/>
-                </a:solidFill>
-                <a:latin typeface="Arial"/>
-              </a:defRPr>
-            </a:pPr>
-            <a:r>
-              <a:t>•  Résilience : Script de supervision (run_agent.py) pour relancer l'agent en moins de 2s lors des déconnexions.</a:t>
+              <a:t>•  Superviseur de résilience : Script run_agent.py surveillant le worker et le relançant automatiquement en moins de 2s en cas de perte de connexion.</a:t>
             </a:r>
           </a:p>
         </p:txBody>
@@ -4682,8 +4762,8 @@
         </p:nvSpPr>
         <p:spPr>
           <a:xfrm>
-            <a:off x="731520" y="457200"/>
-            <a:ext cx="10698480" cy="1097280"/>
+            <a:off x="731520" y="365760"/>
+            <a:ext cx="10698480" cy="1005840"/>
           </a:xfrm>
           <a:prstGeom prst="rect">
             <a:avLst/>
@@ -4718,8 +4798,8 @@
         </p:nvSpPr>
         <p:spPr>
           <a:xfrm>
-            <a:off x="731520" y="1371600"/>
-            <a:ext cx="10698480" cy="731520"/>
+            <a:off x="731520" y="1188720"/>
+            <a:ext cx="10698480" cy="640080"/>
           </a:xfrm>
           <a:prstGeom prst="rect">
             <a:avLst/>
@@ -4754,8 +4834,8 @@
         </p:nvSpPr>
         <p:spPr>
           <a:xfrm>
-            <a:off x="731520" y="2194560"/>
-            <a:ext cx="10698480" cy="4114800"/>
+            <a:off x="731520" y="1920240"/>
+            <a:ext cx="10698480" cy="4389120"/>
           </a:xfrm>
           <a:prstGeom prst="rect">
             <a:avLst/>
@@ -4770,9 +4850,9 @@
           <a:p>
             <a:pPr>
               <a:spcAft>
-                <a:spcPts val="1600"/>
+                <a:spcPts val="1200"/>
               </a:spcAft>
-              <a:defRPr sz="1800">
+              <a:defRPr sz="1700">
                 <a:solidFill>
                   <a:srgbClr val="E2E8F0"/>
                 </a:solidFill>
@@ -4780,15 +4860,15 @@
               </a:defRPr>
             </a:pPr>
             <a:r>
-              <a:t>•  1. Matériel GPU lourd : VRAM de 16-24 Go requise, loyer cloud GPU NVIDIA A100/H100 mensuel récurrent élevé.</a:t>
+              <a:t>•  1. Matériel GPU lourd : Requiert 16-24 Go de VRAM dédiée (Helium 7B + Mimi). Coût cloud mensuel récurrent élevé (A100/H100).</a:t>
             </a:r>
           </a:p>
           <a:p>
             <a:pPr>
               <a:spcAft>
-                <a:spcPts val="1600"/>
+                <a:spcPts val="1200"/>
               </a:spcAft>
-              <a:defRPr sz="1800">
+              <a:defRPr sz="1700">
                 <a:solidFill>
                   <a:srgbClr val="E2E8F0"/>
                 </a:solidFill>
@@ -4796,15 +4876,15 @@
               </a:defRPr>
             </a:pPr>
             <a:r>
-              <a:t>•  2. Couche de transport audio : Nécessité de développer l'interfaçage WebSocket Mimi et la gestion de la gigue réseau.</a:t>
+              <a:t>•  2. Couche de transport audio : Nécessité de développer l'interfaçage WebSocket, le codec Mimi et le Jitter Buffer.</a:t>
             </a:r>
           </a:p>
           <a:p>
             <a:pPr>
               <a:spcAft>
-                <a:spcPts val="1600"/>
+                <a:spcPts val="1200"/>
               </a:spcAft>
-              <a:defRPr sz="1800">
+              <a:defRPr sz="1700">
                 <a:solidFill>
                   <a:srgbClr val="E2E8F0"/>
                 </a:solidFill>
@@ -4818,9 +4898,9 @@
           <a:p>
             <a:pPr>
               <a:spcAft>
-                <a:spcPts val="1600"/>
+                <a:spcPts val="1200"/>
               </a:spcAft>
-              <a:defRPr sz="1800">
+              <a:defRPr sz="1700">
                 <a:solidFill>
                   <a:srgbClr val="E2E8F0"/>
                 </a:solidFill>
@@ -4828,15 +4908,15 @@
               </a:defRPr>
             </a:pPr>
             <a:r>
-              <a:t>•  4. Windows non supporté : Obligation d'utiliser WSL2 (latence et complexité de partage de ressource GPU).</a:t>
+              <a:t>•  4. Windows non supporté : Kyutai cible Linux/macOS. Obligation d'utiliser WSL2 (complexité de partage GPU, latence).</a:t>
             </a:r>
           </a:p>
           <a:p>
             <a:pPr>
               <a:spcAft>
-                <a:spcPts val="1600"/>
+                <a:spcPts val="1200"/>
               </a:spcAft>
-              <a:defRPr sz="1800">
+              <a:defRPr sz="1700">
                 <a:solidFill>
                   <a:srgbClr val="E2E8F0"/>
                 </a:solidFill>
@@ -4844,15 +4924,15 @@
               </a:defRPr>
             </a:pPr>
             <a:r>
-              <a:t>•  5. Pas de VoIP/SIP natif : Nécessité de ponts RTC complexes pour connecter des téléphones réels.</a:t>
+              <a:t>•  5. Pas de VoIP/SIP natif : Nécessité de développer des ponts RTC complexes pour connecter des téléphones réels.</a:t>
             </a:r>
           </a:p>
           <a:p>
             <a:pPr>
               <a:spcAft>
-                <a:spcPts val="1600"/>
+                <a:spcPts val="1200"/>
               </a:spcAft>
-              <a:defRPr sz="1800">
+              <a:defRPr sz="1700">
                 <a:solidFill>
                   <a:srgbClr val="E2E8F0"/>
                 </a:solidFill>
@@ -4860,7 +4940,7 @@
               </a:defRPr>
             </a:pPr>
             <a:r>
-              <a:t>•  6. Pas de Function Calling : Analyseur de monologue intérieur obligatoire pour déclencher des actions bancaires.</a:t>
+              <a:t>•  6. Pas de Function Calling : Analyseur de monologue intérieur obligatoire pour exécuter des actions bancaires.</a:t>
             </a:r>
           </a:p>
         </p:txBody>

</xml_diff>